<commit_message>
Put the Mentimeter code on the claim slides
Co-Authored-By: Claude Fable 5.1 <noreply@anthropic.com>
</commit_message>
<xml_diff>
--- a/slides/src/rag_iii_claims_english.pptx
+++ b/slides/src/rag_iii_claims_english.pptx
@@ -49241,7 +49241,7 @@
                 </a:solidFill>
                 <a:latin typeface="Verdana"/>
               </a:rPr>
-              <a:t>Mentimeter code: ____</a:t>
+              <a:t>menti.com, code 7946 2006</a:t>
             </a:r>
           </a:p>
         </p:txBody>
@@ -53819,7 +53819,7 @@
                 </a:solidFill>
                 <a:latin typeface="Verdana"/>
               </a:rPr>
-              <a:t>Mentimeter code: ____</a:t>
+              <a:t>menti.com, code 7946 2006</a:t>
             </a:r>
           </a:p>
         </p:txBody>

</xml_diff>